<commit_message>
feat: enhance session saving logic and add chat nudges based on user behavior
</commit_message>
<xml_diff>
--- a/Adaptive_Study_Companion.pptx
+++ b/Adaptive_Study_Companion.pptx
@@ -348,7 +348,7 @@
     </p:spTree>
     <p:extLst>
       <p:ext uri="{BB962C8B-B14F-4D97-AF65-F5344CB8AC3E}">
-        <p14:creationId xmlns:p14="http://schemas.microsoft.com/office/powerpoint/2010/main" xmlns="" val="3168075583"/>
+        <p14:creationId xmlns="" xmlns:p14="http://schemas.microsoft.com/office/powerpoint/2010/main" val="3168075583"/>
       </p:ext>
     </p:extLst>
   </p:cSld>
@@ -520,7 +520,7 @@
     </p:spTree>
     <p:extLst>
       <p:ext uri="{BB962C8B-B14F-4D97-AF65-F5344CB8AC3E}">
-        <p14:creationId xmlns:p14="http://schemas.microsoft.com/office/powerpoint/2010/main" xmlns="" val="2910927964"/>
+        <p14:creationId xmlns="" xmlns:p14="http://schemas.microsoft.com/office/powerpoint/2010/main" val="2910927964"/>
       </p:ext>
     </p:extLst>
   </p:cSld>
@@ -702,7 +702,7 @@
     </p:spTree>
     <p:extLst>
       <p:ext uri="{BB962C8B-B14F-4D97-AF65-F5344CB8AC3E}">
-        <p14:creationId xmlns:p14="http://schemas.microsoft.com/office/powerpoint/2010/main" xmlns="" val="3612223792"/>
+        <p14:creationId xmlns="" xmlns:p14="http://schemas.microsoft.com/office/powerpoint/2010/main" val="3612223792"/>
       </p:ext>
     </p:extLst>
   </p:cSld>
@@ -874,7 +874,7 @@
     </p:spTree>
     <p:extLst>
       <p:ext uri="{BB962C8B-B14F-4D97-AF65-F5344CB8AC3E}">
-        <p14:creationId xmlns:p14="http://schemas.microsoft.com/office/powerpoint/2010/main" xmlns="" val="2614314258"/>
+        <p14:creationId xmlns="" xmlns:p14="http://schemas.microsoft.com/office/powerpoint/2010/main" val="2614314258"/>
       </p:ext>
     </p:extLst>
   </p:cSld>
@@ -1122,7 +1122,7 @@
     </p:spTree>
     <p:extLst>
       <p:ext uri="{BB962C8B-B14F-4D97-AF65-F5344CB8AC3E}">
-        <p14:creationId xmlns:p14="http://schemas.microsoft.com/office/powerpoint/2010/main" xmlns="" val="960648375"/>
+        <p14:creationId xmlns="" xmlns:p14="http://schemas.microsoft.com/office/powerpoint/2010/main" val="960648375"/>
       </p:ext>
     </p:extLst>
   </p:cSld>
@@ -1412,7 +1412,7 @@
     </p:spTree>
     <p:extLst>
       <p:ext uri="{BB962C8B-B14F-4D97-AF65-F5344CB8AC3E}">
-        <p14:creationId xmlns:p14="http://schemas.microsoft.com/office/powerpoint/2010/main" xmlns="" val="2782244947"/>
+        <p14:creationId xmlns="" xmlns:p14="http://schemas.microsoft.com/office/powerpoint/2010/main" val="2782244947"/>
       </p:ext>
     </p:extLst>
   </p:cSld>
@@ -1836,7 +1836,7 @@
     </p:spTree>
     <p:extLst>
       <p:ext uri="{BB962C8B-B14F-4D97-AF65-F5344CB8AC3E}">
-        <p14:creationId xmlns:p14="http://schemas.microsoft.com/office/powerpoint/2010/main" xmlns="" val="990158736"/>
+        <p14:creationId xmlns="" xmlns:p14="http://schemas.microsoft.com/office/powerpoint/2010/main" val="990158736"/>
       </p:ext>
     </p:extLst>
   </p:cSld>
@@ -1956,7 +1956,7 @@
     </p:spTree>
     <p:extLst>
       <p:ext uri="{BB962C8B-B14F-4D97-AF65-F5344CB8AC3E}">
-        <p14:creationId xmlns:p14="http://schemas.microsoft.com/office/powerpoint/2010/main" xmlns="" val="727027711"/>
+        <p14:creationId xmlns="" xmlns:p14="http://schemas.microsoft.com/office/powerpoint/2010/main" val="727027711"/>
       </p:ext>
     </p:extLst>
   </p:cSld>
@@ -2053,7 +2053,7 @@
     </p:spTree>
     <p:extLst>
       <p:ext uri="{BB962C8B-B14F-4D97-AF65-F5344CB8AC3E}">
-        <p14:creationId xmlns:p14="http://schemas.microsoft.com/office/powerpoint/2010/main" xmlns="" val="1212999818"/>
+        <p14:creationId xmlns="" xmlns:p14="http://schemas.microsoft.com/office/powerpoint/2010/main" val="1212999818"/>
       </p:ext>
     </p:extLst>
   </p:cSld>
@@ -2332,7 +2332,7 @@
     </p:spTree>
     <p:extLst>
       <p:ext uri="{BB962C8B-B14F-4D97-AF65-F5344CB8AC3E}">
-        <p14:creationId xmlns:p14="http://schemas.microsoft.com/office/powerpoint/2010/main" xmlns="" val="1840726560"/>
+        <p14:creationId xmlns="" xmlns:p14="http://schemas.microsoft.com/office/powerpoint/2010/main" val="1840726560"/>
       </p:ext>
     </p:extLst>
   </p:cSld>
@@ -2587,7 +2587,7 @@
     </p:spTree>
     <p:extLst>
       <p:ext uri="{BB962C8B-B14F-4D97-AF65-F5344CB8AC3E}">
-        <p14:creationId xmlns:p14="http://schemas.microsoft.com/office/powerpoint/2010/main" xmlns="" val="3889236939"/>
+        <p14:creationId xmlns="" xmlns:p14="http://schemas.microsoft.com/office/powerpoint/2010/main" val="3889236939"/>
       </p:ext>
     </p:extLst>
   </p:cSld>
@@ -2838,7 +2838,7 @@
     </p:spTree>
     <p:extLst>
       <p:ext uri="{BB962C8B-B14F-4D97-AF65-F5344CB8AC3E}">
-        <p14:creationId xmlns:p14="http://schemas.microsoft.com/office/powerpoint/2010/main" xmlns="" val="2209977519"/>
+        <p14:creationId xmlns="" xmlns:p14="http://schemas.microsoft.com/office/powerpoint/2010/main" val="2209977519"/>
       </p:ext>
     </p:extLst>
   </p:cSld>
@@ -3369,7 +3369,7 @@
         <p:spPr>
           <a:xfrm>
             <a:off x="457200" y="4069080"/>
-            <a:ext cx="7315200" cy="365760"/>
+            <a:ext cx="7315200" cy="292388"/>
           </a:xfrm>
           <a:prstGeom prst="rect">
             <a:avLst/>
@@ -3389,8 +3389,21 @@
                   <a:srgbClr val="94A3B8"/>
                 </a:solidFill>
               </a:rPr>
-              <a:t>Hackathon  ·  PS 09  ·  Team Adaptive AI</a:t>
-            </a:r>
+              <a:t>Hackathon  ·  PS 09  ·  Team </a:t>
+            </a:r>
+            <a:r>
+              <a:rPr lang="en-US" sz="1300" b="1" dirty="0" err="1" smtClean="0">
+                <a:solidFill>
+                  <a:srgbClr val="94A3B8"/>
+                </a:solidFill>
+              </a:rPr>
+              <a:t>babyBot</a:t>
+            </a:r>
+            <a:endParaRPr sz="1300" b="1">
+              <a:solidFill>
+                <a:srgbClr val="94A3B8"/>
+              </a:solidFill>
+            </a:endParaRPr>
           </a:p>
         </p:txBody>
       </p:sp>
@@ -3508,7 +3521,7 @@
         </p:nvSpPr>
         <p:spPr>
           <a:xfrm>
-            <a:off x="8961120" y="3657600"/>
+            <a:off x="8961120" y="4502331"/>
             <a:ext cx="2651760" cy="640080"/>
           </a:xfrm>
           <a:prstGeom prst="rect">
@@ -3550,6 +3563,67 @@
               </a:rPr>
               <a:t>Fatigued</a:t>
             </a:r>
+          </a:p>
+        </p:txBody>
+      </p:sp>
+      <p:sp>
+        <p:nvSpPr>
+          <p:cNvPr id="13" name="Rectangle 12"/>
+          <p:cNvSpPr/>
+          <p:nvPr/>
+        </p:nvSpPr>
+        <p:spPr>
+          <a:xfrm>
+            <a:off x="8980172" y="3657599"/>
+            <a:ext cx="2651760" cy="640080"/>
+          </a:xfrm>
+          <a:prstGeom prst="rect">
+            <a:avLst/>
+          </a:prstGeom>
+          <a:solidFill>
+            <a:schemeClr val="tx2">
+              <a:lumMod val="40000"/>
+              <a:lumOff val="60000"/>
+            </a:schemeClr>
+          </a:solidFill>
+          <a:ln w="15240">
+            <a:solidFill>
+              <a:srgbClr val="0099FF"/>
+            </a:solidFill>
+          </a:ln>
+        </p:spPr>
+        <p:style>
+          <a:lnRef idx="1">
+            <a:schemeClr val="accent1"/>
+          </a:lnRef>
+          <a:fillRef idx="3">
+            <a:schemeClr val="accent1"/>
+          </a:fillRef>
+          <a:effectRef idx="2">
+            <a:schemeClr val="accent1"/>
+          </a:effectRef>
+          <a:fontRef idx="minor">
+            <a:schemeClr val="lt1"/>
+          </a:fontRef>
+        </p:style>
+        <p:txBody>
+          <a:bodyPr rtlCol="0" anchor="ctr"/>
+          <a:lstStyle/>
+          <a:p>
+            <a:pPr algn="ctr"/>
+            <a:r>
+              <a:rPr lang="en-US" sz="1600" b="1" dirty="0" smtClean="0">
+                <a:solidFill>
+                  <a:srgbClr val="0099FF"/>
+                </a:solidFill>
+              </a:rPr>
+              <a:t>Boredom</a:t>
+            </a:r>
+            <a:endParaRPr sz="1600" b="1">
+              <a:solidFill>
+                <a:srgbClr val="0099FF"/>
+              </a:solidFill>
+            </a:endParaRPr>
           </a:p>
         </p:txBody>
       </p:sp>

</xml_diff>